<commit_message>
Jag har lagt till slide 2
</commit_message>
<xml_diff>
--- a/Bogdans_Presentation.pptx
+++ b/Bogdans_Presentation.pptx
@@ -4,6 +4,12 @@
   <p:sldMasterIdLst>
     <p:sldMasterId id="2147483648" r:id="rId1"/>
   </p:sldMasterIdLst>
+  <p:sldIdLst>
+    <p:sldId id="256" r:id="rId7"/>
+    <p:sldId id="257" r:id="rId8"/>
+    <p:sldId id="258" r:id="rId9"/>
+    <p:sldId id="259" r:id="rId10"/>
+  </p:sldIdLst>
   <p:sldSz cx="9144000" cy="6858000" type="screen4x3"/>
   <p:notesSz cx="6858000" cy="9144000"/>
   <p:defaultTextStyle>
@@ -3073,6 +3079,202 @@
     </p:otherStyle>
   </p:txStyles>
 </p:sldMaster>
+</file>
+
+<file path=ppt/slides/slide1.xml><?xml version="1.0" encoding="utf-8"?>
+<p:sld xmlns:a="http://schemas.openxmlformats.org/drawingml/2006/main" xmlns:p="http://schemas.openxmlformats.org/presentationml/2006/main" xmlns:r="http://schemas.openxmlformats.org/officeDocument/2006/relationships">
+  <p:cSld>
+    <p:spTree>
+      <p:nvGrpSpPr>
+        <p:cNvPr id="1" name=""/>
+        <p:cNvGrpSpPr/>
+        <p:nvPr/>
+      </p:nvGrpSpPr>
+      <p:grpSpPr/>
+      <p:sp>
+        <p:nvSpPr>
+          <p:cNvPr id="2" name="Title 1"/>
+          <p:cNvSpPr>
+            <a:spLocks noGrp="1"/>
+          </p:cNvSpPr>
+          <p:nvPr>
+            <p:ph type="title"/>
+          </p:nvPr>
+        </p:nvSpPr>
+        <p:spPr/>
+        <p:txBody>
+          <a:bodyPr/>
+          <a:lstStyle/>
+          <a:p>
+            <a:r>
+              <a:t>Oil Price Over Time</a:t>
+            </a:r>
+          </a:p>
+        </p:txBody>
+      </p:sp>
+    </p:spTree>
+  </p:cSld>
+  <p:clrMapOvr>
+    <a:masterClrMapping/>
+  </p:clrMapOvr>
+</p:sld>
+</file>
+
+<file path=ppt/slides/slide2.xml><?xml version="1.0" encoding="utf-8"?>
+<p:sld xmlns:a="http://schemas.openxmlformats.org/drawingml/2006/main" xmlns:p="http://schemas.openxmlformats.org/presentationml/2006/main" xmlns:r="http://schemas.openxmlformats.org/officeDocument/2006/relationships">
+  <p:cSld>
+    <p:spTree>
+      <p:nvGrpSpPr>
+        <p:cNvPr id="1" name=""/>
+        <p:cNvGrpSpPr/>
+        <p:nvPr/>
+      </p:nvGrpSpPr>
+      <p:grpSpPr/>
+      <p:sp>
+        <p:nvSpPr>
+          <p:cNvPr id="2" name="Title 1"/>
+          <p:cNvSpPr>
+            <a:spLocks noGrp="1"/>
+          </p:cNvSpPr>
+          <p:nvPr>
+            <p:ph type="title"/>
+          </p:nvPr>
+        </p:nvSpPr>
+        <p:spPr/>
+        <p:txBody>
+          <a:bodyPr/>
+          <a:lstStyle/>
+          <a:p>
+            <a:r>
+              <a:t>Highest and lowest price</a:t>
+            </a:r>
+          </a:p>
+        </p:txBody>
+      </p:sp>
+      <p:pic>
+        <p:nvPicPr>
+          <p:cNvPr id="3" name="Picture 2" descr="oil_price_graph.png"/>
+          <p:cNvPicPr>
+            <a:picLocks noChangeAspect="1"/>
+          </p:cNvPicPr>
+          <p:nvPr/>
+        </p:nvPicPr>
+        <p:blipFill>
+          <a:blip r:embed="rId2"/>
+          <a:stretch>
+            <a:fillRect/>
+          </a:stretch>
+        </p:blipFill>
+        <p:spPr>
+          <a:xfrm>
+            <a:off x="0" y="0"/>
+            <a:ext cx="9144000" cy="6858000"/>
+          </a:xfrm>
+          <a:prstGeom prst="rect">
+            <a:avLst/>
+          </a:prstGeom>
+        </p:spPr>
+      </p:pic>
+    </p:spTree>
+  </p:cSld>
+  <p:clrMapOvr>
+    <a:masterClrMapping/>
+  </p:clrMapOvr>
+</p:sld>
+</file>
+
+<file path=ppt/slides/slide3.xml><?xml version="1.0" encoding="utf-8"?>
+<p:sld xmlns:a="http://schemas.openxmlformats.org/drawingml/2006/main" xmlns:p="http://schemas.openxmlformats.org/presentationml/2006/main" xmlns:r="http://schemas.openxmlformats.org/officeDocument/2006/relationships">
+  <p:cSld>
+    <p:spTree>
+      <p:nvGrpSpPr>
+        <p:cNvPr id="1" name=""/>
+        <p:cNvGrpSpPr/>
+        <p:nvPr/>
+      </p:nvGrpSpPr>
+      <p:grpSpPr/>
+      <p:sp>
+        <p:nvSpPr>
+          <p:cNvPr id="2" name="Title 1"/>
+          <p:cNvSpPr>
+            <a:spLocks noGrp="1"/>
+          </p:cNvSpPr>
+          <p:nvPr>
+            <p:ph type="title"/>
+          </p:nvPr>
+        </p:nvSpPr>
+        <p:spPr/>
+        <p:txBody>
+          <a:bodyPr/>
+          <a:lstStyle/>
+          <a:p/>
+        </p:txBody>
+      </p:sp>
+    </p:spTree>
+  </p:cSld>
+  <p:clrMapOvr>
+    <a:masterClrMapping/>
+  </p:clrMapOvr>
+</p:sld>
+</file>
+
+<file path=ppt/slides/slide4.xml><?xml version="1.0" encoding="utf-8"?>
+<p:sld xmlns:a="http://schemas.openxmlformats.org/drawingml/2006/main" xmlns:p="http://schemas.openxmlformats.org/presentationml/2006/main" xmlns:r="http://schemas.openxmlformats.org/officeDocument/2006/relationships">
+  <p:cSld>
+    <p:spTree>
+      <p:nvGrpSpPr>
+        <p:cNvPr id="1" name=""/>
+        <p:cNvGrpSpPr/>
+        <p:nvPr/>
+      </p:nvGrpSpPr>
+      <p:grpSpPr/>
+      <p:sp>
+        <p:nvSpPr>
+          <p:cNvPr id="2" name="Title 1"/>
+          <p:cNvSpPr>
+            <a:spLocks noGrp="1"/>
+          </p:cNvSpPr>
+          <p:nvPr>
+            <p:ph type="title"/>
+          </p:nvPr>
+        </p:nvSpPr>
+        <p:spPr/>
+        <p:txBody>
+          <a:bodyPr/>
+          <a:lstStyle/>
+          <a:p/>
+        </p:txBody>
+      </p:sp>
+      <p:pic>
+        <p:nvPicPr>
+          <p:cNvPr id="3" name="Picture 2" descr="oil_price_percentage_change.png"/>
+          <p:cNvPicPr>
+            <a:picLocks noChangeAspect="1"/>
+          </p:cNvPicPr>
+          <p:nvPr/>
+        </p:nvPicPr>
+        <p:blipFill>
+          <a:blip r:embed="rId2"/>
+          <a:stretch>
+            <a:fillRect/>
+          </a:stretch>
+        </p:blipFill>
+        <p:spPr>
+          <a:xfrm>
+            <a:off x="0" y="0"/>
+            <a:ext cx="9144000" cy="6858000"/>
+          </a:xfrm>
+          <a:prstGeom prst="rect">
+            <a:avLst/>
+          </a:prstGeom>
+        </p:spPr>
+      </p:pic>
+    </p:spTree>
+  </p:cSld>
+  <p:clrMapOvr>
+    <a:masterClrMapping/>
+  </p:clrMapOvr>
+</p:sld>
 </file>
 
 <file path=ppt/theme/theme1.xml><?xml version="1.0" encoding="utf-8"?>

</xml_diff>

<commit_message>
la till flera slides
</commit_message>
<xml_diff>
--- a/Bogdans_Presentation.pptx
+++ b/Bogdans_Presentation.pptx
@@ -9,6 +9,9 @@
     <p:sldId id="257" r:id="rId8"/>
     <p:sldId id="258" r:id="rId9"/>
     <p:sldId id="259" r:id="rId10"/>
+    <p:sldId id="260" r:id="rId11"/>
+    <p:sldId id="261" r:id="rId12"/>
+    <p:sldId id="262" r:id="rId13"/>
   </p:sldIdLst>
   <p:sldSz cx="9144000" cy="6858000" type="screen4x3"/>
   <p:notesSz cx="6858000" cy="9144000"/>
@@ -3146,7 +3149,7 @@
           <a:lstStyle/>
           <a:p>
             <a:r>
-              <a:t>Highest and lowest price</a:t>
+              <a:t>Highest and Lowest Oil Price</a:t>
             </a:r>
           </a:p>
         </p:txBody>
@@ -3207,7 +3210,51 @@
         <p:txBody>
           <a:bodyPr/>
           <a:lstStyle/>
-          <a:p/>
+          <a:p>
+            <a:r>
+              <a:t>Oil Price Statistics</a:t>
+            </a:r>
+          </a:p>
+        </p:txBody>
+      </p:sp>
+      <p:sp>
+        <p:nvSpPr>
+          <p:cNvPr id="3" name="TextBox 2"/>
+          <p:cNvSpPr txBox="1"/>
+          <p:nvPr/>
+        </p:nvSpPr>
+        <p:spPr>
+          <a:xfrm>
+            <a:off x="1000000" y="2500000"/>
+            <a:ext cx="7000000" cy="3000000"/>
+          </a:xfrm>
+          <a:prstGeom prst="rect">
+            <a:avLst/>
+          </a:prstGeom>
+          <a:noFill/>
+        </p:spPr>
+        <p:txBody>
+          <a:bodyPr wrap="square">
+            <a:spAutoFit/>
+          </a:bodyPr>
+          <a:lstStyle/>
+          <a:p>
+            <a:pPr>
+              <a:defRPr sz="2400"/>
+            </a:pPr>
+            <a:r>
+              <a:t>Highest price: $140.0 on 2008-06-01</a:t>
+            </a:r>
+          </a:p>
+          <a:p>
+            <a:br/>
+            <a:pPr>
+              <a:defRPr sz="2400"/>
+            </a:pPr>
+            <a:r>
+              <a:t>Lowest price: $10.42 on 1986-03-01</a:t>
+            </a:r>
+          </a:p>
         </p:txBody>
       </p:sp>
     </p:spTree>
@@ -3242,12 +3289,221 @@
         <p:txBody>
           <a:bodyPr/>
           <a:lstStyle/>
-          <a:p/>
+          <a:p>
+            <a:r>
+              <a:t>Oil Price Percentage Change</a:t>
+            </a:r>
+          </a:p>
         </p:txBody>
       </p:sp>
       <p:pic>
         <p:nvPicPr>
           <p:cNvPr id="3" name="Picture 2" descr="oil_price_percentage_change.png"/>
+          <p:cNvPicPr>
+            <a:picLocks noChangeAspect="1"/>
+          </p:cNvPicPr>
+          <p:nvPr/>
+        </p:nvPicPr>
+        <p:blipFill>
+          <a:blip r:embed="rId2"/>
+          <a:stretch>
+            <a:fillRect/>
+          </a:stretch>
+        </p:blipFill>
+        <p:spPr>
+          <a:xfrm>
+            <a:off x="0" y="0"/>
+            <a:ext cx="9144000" cy="6858000"/>
+          </a:xfrm>
+          <a:prstGeom prst="rect">
+            <a:avLst/>
+          </a:prstGeom>
+        </p:spPr>
+      </p:pic>
+    </p:spTree>
+  </p:cSld>
+  <p:clrMapOvr>
+    <a:masterClrMapping/>
+  </p:clrMapOvr>
+</p:sld>
+</file>
+
+<file path=ppt/slides/slide5.xml><?xml version="1.0" encoding="utf-8"?>
+<p:sld xmlns:a="http://schemas.openxmlformats.org/drawingml/2006/main" xmlns:p="http://schemas.openxmlformats.org/presentationml/2006/main" xmlns:r="http://schemas.openxmlformats.org/officeDocument/2006/relationships">
+  <p:cSld>
+    <p:spTree>
+      <p:nvGrpSpPr>
+        <p:cNvPr id="1" name=""/>
+        <p:cNvGrpSpPr/>
+        <p:nvPr/>
+      </p:nvGrpSpPr>
+      <p:grpSpPr/>
+      <p:sp>
+        <p:nvSpPr>
+          <p:cNvPr id="2" name="Title 1"/>
+          <p:cNvSpPr>
+            <a:spLocks noGrp="1"/>
+          </p:cNvSpPr>
+          <p:nvPr>
+            <p:ph type="title"/>
+          </p:nvPr>
+        </p:nvSpPr>
+        <p:spPr/>
+        <p:txBody>
+          <a:bodyPr/>
+          <a:lstStyle/>
+          <a:p>
+            <a:r>
+              <a:t>US CPI Over Time</a:t>
+            </a:r>
+          </a:p>
+        </p:txBody>
+      </p:sp>
+      <p:pic>
+        <p:nvPicPr>
+          <p:cNvPr id="3" name="Picture 2" descr="inflation_rate_graph.png"/>
+          <p:cNvPicPr>
+            <a:picLocks noChangeAspect="1"/>
+          </p:cNvPicPr>
+          <p:nvPr/>
+        </p:nvPicPr>
+        <p:blipFill>
+          <a:blip r:embed="rId2"/>
+          <a:stretch>
+            <a:fillRect/>
+          </a:stretch>
+        </p:blipFill>
+        <p:spPr>
+          <a:xfrm>
+            <a:off x="0" y="0"/>
+            <a:ext cx="9144000" cy="6858000"/>
+          </a:xfrm>
+          <a:prstGeom prst="rect">
+            <a:avLst/>
+          </a:prstGeom>
+        </p:spPr>
+      </p:pic>
+    </p:spTree>
+  </p:cSld>
+  <p:clrMapOvr>
+    <a:masterClrMapping/>
+  </p:clrMapOvr>
+</p:sld>
+</file>
+
+<file path=ppt/slides/slide6.xml><?xml version="1.0" encoding="utf-8"?>
+<p:sld xmlns:a="http://schemas.openxmlformats.org/drawingml/2006/main" xmlns:p="http://schemas.openxmlformats.org/presentationml/2006/main" xmlns:r="http://schemas.openxmlformats.org/officeDocument/2006/relationships">
+  <p:cSld>
+    <p:spTree>
+      <p:nvGrpSpPr>
+        <p:cNvPr id="1" name=""/>
+        <p:cNvGrpSpPr/>
+        <p:nvPr/>
+      </p:nvGrpSpPr>
+      <p:grpSpPr/>
+      <p:sp>
+        <p:nvSpPr>
+          <p:cNvPr id="2" name="Title 1"/>
+          <p:cNvSpPr>
+            <a:spLocks noGrp="1"/>
+          </p:cNvSpPr>
+          <p:nvPr>
+            <p:ph type="title"/>
+          </p:nvPr>
+        </p:nvSpPr>
+        <p:spPr/>
+        <p:txBody>
+          <a:bodyPr/>
+          <a:lstStyle/>
+          <a:p>
+            <a:r>
+              <a:t>Highest and Lowest Inflation CPI</a:t>
+            </a:r>
+          </a:p>
+        </p:txBody>
+      </p:sp>
+      <p:sp>
+        <p:nvSpPr>
+          <p:cNvPr id="3" name="TextBox 2"/>
+          <p:cNvSpPr txBox="1"/>
+          <p:nvPr/>
+        </p:nvSpPr>
+        <p:spPr>
+          <a:xfrm>
+            <a:off x="1000000" y="2500000"/>
+            <a:ext cx="7000000" cy="3000000"/>
+          </a:xfrm>
+          <a:prstGeom prst="rect">
+            <a:avLst/>
+          </a:prstGeom>
+          <a:noFill/>
+        </p:spPr>
+        <p:txBody>
+          <a:bodyPr wrap="square">
+            <a:spAutoFit/>
+          </a:bodyPr>
+          <a:lstStyle/>
+          <a:p>
+            <a:pPr>
+              <a:defRPr sz="2400"/>
+            </a:pPr>
+            <a:r>
+              <a:t>Highest CPI: 271.696 on 2021-01-06</a:t>
+            </a:r>
+          </a:p>
+          <a:p>
+            <a:br/>
+            <a:pPr>
+              <a:defRPr sz="2400"/>
+            </a:pPr>
+            <a:r>
+              <a:t>Lowest CPI: 1.003 on 2021-01-07</a:t>
+            </a:r>
+          </a:p>
+        </p:txBody>
+      </p:sp>
+    </p:spTree>
+  </p:cSld>
+  <p:clrMapOvr>
+    <a:masterClrMapping/>
+  </p:clrMapOvr>
+</p:sld>
+</file>
+
+<file path=ppt/slides/slide7.xml><?xml version="1.0" encoding="utf-8"?>
+<p:sld xmlns:a="http://schemas.openxmlformats.org/drawingml/2006/main" xmlns:p="http://schemas.openxmlformats.org/presentationml/2006/main" xmlns:r="http://schemas.openxmlformats.org/officeDocument/2006/relationships">
+  <p:cSld>
+    <p:spTree>
+      <p:nvGrpSpPr>
+        <p:cNvPr id="1" name=""/>
+        <p:cNvGrpSpPr/>
+        <p:nvPr/>
+      </p:nvGrpSpPr>
+      <p:grpSpPr/>
+      <p:sp>
+        <p:nvSpPr>
+          <p:cNvPr id="2" name="Title 1"/>
+          <p:cNvSpPr>
+            <a:spLocks noGrp="1"/>
+          </p:cNvSpPr>
+          <p:nvPr>
+            <p:ph type="title"/>
+          </p:nvPr>
+        </p:nvSpPr>
+        <p:spPr/>
+        <p:txBody>
+          <a:bodyPr/>
+          <a:lstStyle/>
+          <a:p>
+            <a:r>
+              <a:t>Inflation Rate vs Oil Price</a:t>
+            </a:r>
+          </a:p>
+        </p:txBody>
+      </p:sp>
+      <p:pic>
+        <p:nvPicPr>
+          <p:cNvPr id="3" name="Picture 2" descr="combined_graph.png"/>
           <p:cNvPicPr>
             <a:picLocks noChangeAspect="1"/>
           </p:cNvPicPr>

</xml_diff>